<commit_message>
Handle tables and bulk pattern descriptions in pattern prep
prep_patterns now tokenises every table cell ({{t1_r2c3}}), records the
original text of each slot as EXAMPLE lines in the notes, lists text it
left alone (SmartArt, charts), and writes a notes CSV. New apply_notes.py
writes pattern IDs and descriptions from that CSV (DROP removes a slide).
The builder fills tables from a list of rows and removes unused rows; the
catalogue shows table shapes and example text per slot. Also fixes empty
note fields being read as the next line.

Co-Authored-By: Claude Opus 5.5 <noreply@anthropic.com>
Claude-Session: https://claude.ai/code/session_011nhCvgpo84M5anDF7zPCA2
</commit_message>
<xml_diff>
--- a/deck-builder/skill/pwc-deck-builder/assets/patterns.pptx
+++ b/deck-builder/skill/pwc-deck-builder/assets/patterns.pptx
@@ -11,6 +11,7 @@
     <p:sldId id="259" r:id="rId11"/>
     <p:sldId id="260" r:id="rId12"/>
     <p:sldId id="261" r:id="rId13"/>
+    <p:sldId id="262" r:id="rId14"/>
   </p:sldIdLst>
   <p:sldSz cx="12191695" cy="6858000" type="screen4x3"/>
   <p:notesSz cx="6858000" cy="9144000"/>
@@ -933,6 +934,91 @@
           <a:p>
             <a:r>
               <a:t>USE WHEN: Current vs future state, challenge vs response, what we heard vs what it means</a:t>
+            </a:r>
+          </a:p>
+        </p:txBody>
+      </p:sp>
+      <p:sp>
+        <p:nvSpPr>
+          <p:cNvPr id="4" name="Slide Number Placeholder 3"/>
+          <p:cNvSpPr>
+            <a:spLocks noGrp="1"/>
+          </p:cNvSpPr>
+          <p:nvPr>
+            <p:ph type="sldNum" idx="5" sz="quarter"/>
+          </p:nvPr>
+        </p:nvSpPr>
+        <p:spPr/>
+      </p:sp>
+    </p:spTree>
+  </p:cSld>
+  <p:clrMapOvr>
+    <a:masterClrMapping/>
+  </p:clrMapOvr>
+</p:notes>
+</file>
+
+<file path=ppt/notesSlides/notesSlide7.xml><?xml version="1.0" encoding="utf-8"?>
+<p:notes xmlns:a="http://schemas.openxmlformats.org/drawingml/2006/main" xmlns:p="http://schemas.openxmlformats.org/presentationml/2006/main" xmlns:r="http://schemas.openxmlformats.org/officeDocument/2006/relationships">
+  <p:cSld>
+    <p:spTree>
+      <p:nvGrpSpPr>
+        <p:cNvPr id="1" name=""/>
+        <p:cNvGrpSpPr/>
+        <p:nvPr/>
+      </p:nvGrpSpPr>
+      <p:grpSpPr>
+        <a:xfrm>
+          <a:off x="0" y="0"/>
+          <a:ext cx="0" cy="0"/>
+          <a:chOff x="0" y="0"/>
+          <a:chExt cx="0" cy="0"/>
+        </a:xfrm>
+      </p:grpSpPr>
+      <p:sp>
+        <p:nvSpPr>
+          <p:cNvPr id="2" name="Slide Image Placeholder 1"/>
+          <p:cNvSpPr>
+            <a:spLocks noGrp="1"/>
+          </p:cNvSpPr>
+          <p:nvPr>
+            <p:ph type="sldImg" idx="2"/>
+          </p:nvPr>
+        </p:nvSpPr>
+        <p:spPr/>
+      </p:sp>
+      <p:sp>
+        <p:nvSpPr>
+          <p:cNvPr id="3" name="Notes Placeholder 2"/>
+          <p:cNvSpPr>
+            <a:spLocks noGrp="1"/>
+          </p:cNvSpPr>
+          <p:nvPr>
+            <p:ph type="body" idx="3" sz="quarter"/>
+          </p:nvPr>
+        </p:nvSpPr>
+        <p:spPr/>
+        <p:txBody>
+          <a:bodyPr/>
+          <a:lstStyle/>
+          <a:p>
+            <a:r>
+              <a:t>PATTERN: GOV_MATRIX</a:t>
+            </a:r>
+          </a:p>
+          <a:p>
+            <a:r>
+              <a:t>PURPOSE: Matrix of activities against forums, owners or phases, with ticks</a:t>
+            </a:r>
+          </a:p>
+          <a:p>
+            <a:r>
+              <a:t>USE WHEN: Governance, RACI or activity-by-phase views with up to 6 rows and 3 columns</a:t>
+            </a:r>
+          </a:p>
+          <a:p>
+            <a:r>
+              <a:t>TABLE t1: 7 rows x 4 columns</a:t>
             </a:r>
           </a:p>
         </p:txBody>
@@ -6706,6 +6792,528 @@
       <p:sp>
         <p:nvSpPr>
           <p:cNvPr id="9" name="source"/>
+          <p:cNvSpPr txBox="1"/>
+          <p:nvPr/>
+        </p:nvSpPr>
+        <p:spPr>
+          <a:xfrm>
+            <a:off x="457200" y="6309360"/>
+            <a:ext cx="9144000" cy="274320"/>
+          </a:xfrm>
+          <a:prstGeom prst="rect">
+            <a:avLst/>
+          </a:prstGeom>
+          <a:noFill/>
+        </p:spPr>
+        <p:txBody>
+          <a:bodyPr wrap="square" anchor="t">
+            <a:spAutoFit/>
+          </a:bodyPr>
+          <a:lstStyle/>
+          <a:p>
+            <a:r>
+              <a:rPr sz="900" b="0">
+                <a:solidFill>
+                  <a:srgbClr val="7F7F7F"/>
+                </a:solidFill>
+              </a:rPr>
+              <a:t>{{source}}</a:t>
+            </a:r>
+          </a:p>
+        </p:txBody>
+      </p:sp>
+    </p:spTree>
+  </p:cSld>
+  <p:clrMapOvr>
+    <a:masterClrMapping/>
+  </p:clrMapOvr>
+</p:sld>
+</file>
+
+<file path=ppt/slides/slide7.xml><?xml version="1.0" encoding="utf-8"?>
+<p:sld xmlns:a="http://schemas.openxmlformats.org/drawingml/2006/main" xmlns:p="http://schemas.openxmlformats.org/presentationml/2006/main" xmlns:r="http://schemas.openxmlformats.org/officeDocument/2006/relationships">
+  <p:cSld>
+    <p:spTree>
+      <p:nvGrpSpPr>
+        <p:cNvPr id="1" name=""/>
+        <p:cNvGrpSpPr/>
+        <p:nvPr/>
+      </p:nvGrpSpPr>
+      <p:grpSpPr/>
+      <p:sp>
+        <p:nvSpPr>
+          <p:cNvPr id="2" name="Title 1"/>
+          <p:cNvSpPr>
+            <a:spLocks noGrp="1"/>
+          </p:cNvSpPr>
+          <p:nvPr>
+            <p:ph type="title"/>
+          </p:nvPr>
+        </p:nvSpPr>
+        <p:spPr>
+          <a:xfrm>
+            <a:off x="457200" y="457200"/>
+            <a:ext cx="11247120" cy="822960"/>
+          </a:xfrm>
+        </p:spPr>
+        <p:txBody>
+          <a:bodyPr wrap="square" anchor="t"/>
+          <a:lstStyle/>
+          <a:p>
+            <a:pPr algn="l"/>
+            <a:r>
+              <a:rPr sz="2400" b="1">
+                <a:solidFill>
+                  <a:srgbClr val="333333"/>
+                </a:solidFill>
+              </a:rPr>
+              <a:t>{{title}}</a:t>
+            </a:r>
+          </a:p>
+        </p:txBody>
+      </p:sp>
+      <p:sp>
+        <p:nvSpPr>
+          <p:cNvPr id="3" name="tracker"/>
+          <p:cNvSpPr txBox="1"/>
+          <p:nvPr/>
+        </p:nvSpPr>
+        <p:spPr>
+          <a:xfrm>
+            <a:off x="457200" y="182880"/>
+            <a:ext cx="7315200" cy="274320"/>
+          </a:xfrm>
+          <a:prstGeom prst="rect">
+            <a:avLst/>
+          </a:prstGeom>
+          <a:noFill/>
+        </p:spPr>
+        <p:txBody>
+          <a:bodyPr wrap="square" anchor="t">
+            <a:spAutoFit/>
+          </a:bodyPr>
+          <a:lstStyle/>
+          <a:p>
+            <a:r>
+              <a:rPr sz="1000" b="0">
+                <a:solidFill>
+                  <a:srgbClr val="7F7F7F"/>
+                </a:solidFill>
+              </a:rPr>
+              <a:t>{{tracker}}</a:t>
+            </a:r>
+          </a:p>
+        </p:txBody>
+      </p:sp>
+      <p:graphicFrame>
+        <p:nvGraphicFramePr>
+          <p:cNvPr id="4" name="t1"/>
+          <p:cNvGraphicFramePr>
+            <a:graphicFrameLocks noGrp="1"/>
+          </p:cNvGraphicFramePr>
+          <p:nvPr/>
+        </p:nvGraphicFramePr>
+        <p:xfrm>
+          <a:off x="457200" y="1554480"/>
+          <a:ext cx="11247120" cy="3200400"/>
+        </p:xfrm>
+        <a:graphic>
+          <a:graphicData uri="http://schemas.openxmlformats.org/drawingml/2006/table">
+            <a:tbl>
+              <a:tblPr firstRow="1" bandRow="1">
+                <a:tableStyleId>{5C22544A-7EE6-4342-B048-85BDC9FD1C3A}</a:tableStyleId>
+              </a:tblPr>
+              <a:tblGrid>
+                <a:gridCol w="4937760"/>
+                <a:gridCol w="2103120"/>
+                <a:gridCol w="2103120"/>
+                <a:gridCol w="2103120"/>
+              </a:tblGrid>
+              <a:tr h="457200">
+                <a:tc>
+                  <a:txBody>
+                    <a:bodyPr/>
+                    <a:lstStyle/>
+                    <a:p>
+                      <a:r>
+                        <a:rPr sz="1200" b="1"/>
+                        <a:t>{{t1_r1c1}}</a:t>
+                      </a:r>
+                    </a:p>
+                  </a:txBody>
+                  <a:tcPr/>
+                </a:tc>
+                <a:tc>
+                  <a:txBody>
+                    <a:bodyPr/>
+                    <a:lstStyle/>
+                    <a:p>
+                      <a:r>
+                        <a:rPr sz="1200" b="1"/>
+                        <a:t>{{t1_r1c2}}</a:t>
+                      </a:r>
+                    </a:p>
+                  </a:txBody>
+                  <a:tcPr/>
+                </a:tc>
+                <a:tc>
+                  <a:txBody>
+                    <a:bodyPr/>
+                    <a:lstStyle/>
+                    <a:p>
+                      <a:r>
+                        <a:rPr sz="1200" b="1"/>
+                        <a:t>{{t1_r1c3}}</a:t>
+                      </a:r>
+                    </a:p>
+                  </a:txBody>
+                  <a:tcPr/>
+                </a:tc>
+                <a:tc>
+                  <a:txBody>
+                    <a:bodyPr/>
+                    <a:lstStyle/>
+                    <a:p>
+                      <a:r>
+                        <a:rPr sz="1200" b="1"/>
+                        <a:t>{{t1_r1c4}}</a:t>
+                      </a:r>
+                    </a:p>
+                  </a:txBody>
+                  <a:tcPr/>
+                </a:tc>
+              </a:tr>
+              <a:tr h="457200">
+                <a:tc>
+                  <a:txBody>
+                    <a:bodyPr/>
+                    <a:lstStyle/>
+                    <a:p>
+                      <a:r>
+                        <a:rPr sz="1100" b="0"/>
+                        <a:t>{{t1_r2c1}}</a:t>
+                      </a:r>
+                    </a:p>
+                  </a:txBody>
+                  <a:tcPr/>
+                </a:tc>
+                <a:tc>
+                  <a:txBody>
+                    <a:bodyPr/>
+                    <a:lstStyle/>
+                    <a:p>
+                      <a:r>
+                        <a:rPr sz="1100" b="0"/>
+                        <a:t>{{t1_r2c2}}</a:t>
+                      </a:r>
+                    </a:p>
+                  </a:txBody>
+                  <a:tcPr/>
+                </a:tc>
+                <a:tc>
+                  <a:txBody>
+                    <a:bodyPr/>
+                    <a:lstStyle/>
+                    <a:p>
+                      <a:r>
+                        <a:rPr sz="1100" b="0"/>
+                        <a:t>{{t1_r2c3}}</a:t>
+                      </a:r>
+                    </a:p>
+                  </a:txBody>
+                  <a:tcPr/>
+                </a:tc>
+                <a:tc>
+                  <a:txBody>
+                    <a:bodyPr/>
+                    <a:lstStyle/>
+                    <a:p>
+                      <a:r>
+                        <a:rPr sz="1100" b="0"/>
+                        <a:t>{{t1_r2c4}}</a:t>
+                      </a:r>
+                    </a:p>
+                  </a:txBody>
+                  <a:tcPr/>
+                </a:tc>
+              </a:tr>
+              <a:tr h="457200">
+                <a:tc>
+                  <a:txBody>
+                    <a:bodyPr/>
+                    <a:lstStyle/>
+                    <a:p>
+                      <a:r>
+                        <a:rPr sz="1100" b="0"/>
+                        <a:t>{{t1_r3c1}}</a:t>
+                      </a:r>
+                    </a:p>
+                  </a:txBody>
+                  <a:tcPr/>
+                </a:tc>
+                <a:tc>
+                  <a:txBody>
+                    <a:bodyPr/>
+                    <a:lstStyle/>
+                    <a:p>
+                      <a:r>
+                        <a:rPr sz="1100" b="0"/>
+                        <a:t>{{t1_r3c2}}</a:t>
+                      </a:r>
+                    </a:p>
+                  </a:txBody>
+                  <a:tcPr/>
+                </a:tc>
+                <a:tc>
+                  <a:txBody>
+                    <a:bodyPr/>
+                    <a:lstStyle/>
+                    <a:p>
+                      <a:r>
+                        <a:rPr sz="1100" b="0"/>
+                        <a:t>{{t1_r3c3}}</a:t>
+                      </a:r>
+                    </a:p>
+                  </a:txBody>
+                  <a:tcPr/>
+                </a:tc>
+                <a:tc>
+                  <a:txBody>
+                    <a:bodyPr/>
+                    <a:lstStyle/>
+                    <a:p>
+                      <a:r>
+                        <a:rPr sz="1100" b="0"/>
+                        <a:t>{{t1_r3c4}}</a:t>
+                      </a:r>
+                    </a:p>
+                  </a:txBody>
+                  <a:tcPr/>
+                </a:tc>
+              </a:tr>
+              <a:tr h="457200">
+                <a:tc>
+                  <a:txBody>
+                    <a:bodyPr/>
+                    <a:lstStyle/>
+                    <a:p>
+                      <a:r>
+                        <a:rPr sz="1100" b="0"/>
+                        <a:t>{{t1_r4c1}}</a:t>
+                      </a:r>
+                    </a:p>
+                  </a:txBody>
+                  <a:tcPr/>
+                </a:tc>
+                <a:tc>
+                  <a:txBody>
+                    <a:bodyPr/>
+                    <a:lstStyle/>
+                    <a:p>
+                      <a:r>
+                        <a:rPr sz="1100" b="0"/>
+                        <a:t>{{t1_r4c2}}</a:t>
+                      </a:r>
+                    </a:p>
+                  </a:txBody>
+                  <a:tcPr/>
+                </a:tc>
+                <a:tc>
+                  <a:txBody>
+                    <a:bodyPr/>
+                    <a:lstStyle/>
+                    <a:p>
+                      <a:r>
+                        <a:rPr sz="1100" b="0"/>
+                        <a:t>{{t1_r4c3}}</a:t>
+                      </a:r>
+                    </a:p>
+                  </a:txBody>
+                  <a:tcPr/>
+                </a:tc>
+                <a:tc>
+                  <a:txBody>
+                    <a:bodyPr/>
+                    <a:lstStyle/>
+                    <a:p>
+                      <a:r>
+                        <a:rPr sz="1100" b="0"/>
+                        <a:t>{{t1_r4c4}}</a:t>
+                      </a:r>
+                    </a:p>
+                  </a:txBody>
+                  <a:tcPr/>
+                </a:tc>
+              </a:tr>
+              <a:tr h="457200">
+                <a:tc>
+                  <a:txBody>
+                    <a:bodyPr/>
+                    <a:lstStyle/>
+                    <a:p>
+                      <a:r>
+                        <a:rPr sz="1100" b="0"/>
+                        <a:t>{{t1_r5c1}}</a:t>
+                      </a:r>
+                    </a:p>
+                  </a:txBody>
+                  <a:tcPr/>
+                </a:tc>
+                <a:tc>
+                  <a:txBody>
+                    <a:bodyPr/>
+                    <a:lstStyle/>
+                    <a:p>
+                      <a:r>
+                        <a:rPr sz="1100" b="0"/>
+                        <a:t>{{t1_r5c2}}</a:t>
+                      </a:r>
+                    </a:p>
+                  </a:txBody>
+                  <a:tcPr/>
+                </a:tc>
+                <a:tc>
+                  <a:txBody>
+                    <a:bodyPr/>
+                    <a:lstStyle/>
+                    <a:p>
+                      <a:r>
+                        <a:rPr sz="1100" b="0"/>
+                        <a:t>{{t1_r5c3}}</a:t>
+                      </a:r>
+                    </a:p>
+                  </a:txBody>
+                  <a:tcPr/>
+                </a:tc>
+                <a:tc>
+                  <a:txBody>
+                    <a:bodyPr/>
+                    <a:lstStyle/>
+                    <a:p>
+                      <a:r>
+                        <a:rPr sz="1100" b="0"/>
+                        <a:t>{{t1_r5c4}}</a:t>
+                      </a:r>
+                    </a:p>
+                  </a:txBody>
+                  <a:tcPr/>
+                </a:tc>
+              </a:tr>
+              <a:tr h="457200">
+                <a:tc>
+                  <a:txBody>
+                    <a:bodyPr/>
+                    <a:lstStyle/>
+                    <a:p>
+                      <a:r>
+                        <a:rPr sz="1100" b="0"/>
+                        <a:t>{{t1_r6c1}}</a:t>
+                      </a:r>
+                    </a:p>
+                  </a:txBody>
+                  <a:tcPr/>
+                </a:tc>
+                <a:tc>
+                  <a:txBody>
+                    <a:bodyPr/>
+                    <a:lstStyle/>
+                    <a:p>
+                      <a:r>
+                        <a:rPr sz="1100" b="0"/>
+                        <a:t>{{t1_r6c2}}</a:t>
+                      </a:r>
+                    </a:p>
+                  </a:txBody>
+                  <a:tcPr/>
+                </a:tc>
+                <a:tc>
+                  <a:txBody>
+                    <a:bodyPr/>
+                    <a:lstStyle/>
+                    <a:p>
+                      <a:r>
+                        <a:rPr sz="1100" b="0"/>
+                        <a:t>{{t1_r6c3}}</a:t>
+                      </a:r>
+                    </a:p>
+                  </a:txBody>
+                  <a:tcPr/>
+                </a:tc>
+                <a:tc>
+                  <a:txBody>
+                    <a:bodyPr/>
+                    <a:lstStyle/>
+                    <a:p>
+                      <a:r>
+                        <a:rPr sz="1100" b="0"/>
+                        <a:t>{{t1_r6c4}}</a:t>
+                      </a:r>
+                    </a:p>
+                  </a:txBody>
+                  <a:tcPr/>
+                </a:tc>
+              </a:tr>
+              <a:tr h="457200">
+                <a:tc>
+                  <a:txBody>
+                    <a:bodyPr/>
+                    <a:lstStyle/>
+                    <a:p>
+                      <a:r>
+                        <a:rPr sz="1100" b="0"/>
+                        <a:t>{{t1_r7c1}}</a:t>
+                      </a:r>
+                    </a:p>
+                  </a:txBody>
+                  <a:tcPr/>
+                </a:tc>
+                <a:tc>
+                  <a:txBody>
+                    <a:bodyPr/>
+                    <a:lstStyle/>
+                    <a:p>
+                      <a:r>
+                        <a:rPr sz="1100" b="0"/>
+                        <a:t>{{t1_r7c2}}</a:t>
+                      </a:r>
+                    </a:p>
+                  </a:txBody>
+                  <a:tcPr/>
+                </a:tc>
+                <a:tc>
+                  <a:txBody>
+                    <a:bodyPr/>
+                    <a:lstStyle/>
+                    <a:p>
+                      <a:r>
+                        <a:rPr sz="1100" b="0"/>
+                        <a:t>{{t1_r7c3}}</a:t>
+                      </a:r>
+                    </a:p>
+                  </a:txBody>
+                  <a:tcPr/>
+                </a:tc>
+                <a:tc>
+                  <a:txBody>
+                    <a:bodyPr/>
+                    <a:lstStyle/>
+                    <a:p>
+                      <a:r>
+                        <a:rPr sz="1100" b="0"/>
+                        <a:t>{{t1_r7c4}}</a:t>
+                      </a:r>
+                    </a:p>
+                  </a:txBody>
+                  <a:tcPr/>
+                </a:tc>
+              </a:tr>
+            </a:tbl>
+          </a:graphicData>
+        </a:graphic>
+      </p:graphicFrame>
+      <p:sp>
+        <p:nvSpPr>
+          <p:cNvPr id="5" name="source"/>
           <p:cNvSpPr txBox="1"/>
           <p:nvPr/>
         </p:nvSpPr>

</xml_diff>